<commit_message>
Snapshot: correzioni dal controllo di coerenza (README, slide, articolo nei bis) e rilavorazione in corso di 00, 01, 04, 06, 09, 12
Co-Authored-By: Claude Fable 5.1 <noreply@anthropic.com>
Claude-Session: https://claude.ai/code/session_01P1BQsLkuhRse3RJB6S6MwQ
</commit_message>
<xml_diff>
--- a/Slides/Presentazione_python_base.pptx
+++ b/Slides/Presentazione_python_base.pptx
@@ -10068,357 +10068,7 @@
 </p:sld>
 </file>
 
-<file path=ppt/slides/slide2.xml><?xml version="1.0" encoding="utf-8"?>
-<p:sld xmlns:a="http://schemas.openxmlformats.org/drawingml/2006/main" xmlns:r="http://schemas.openxmlformats.org/officeDocument/2006/relationships" xmlns:p="http://schemas.openxmlformats.org/presentationml/2006/main">
-  <p:cSld>
-    <p:spTree>
-      <p:nvGrpSpPr>
-        <p:cNvPr id="1" name=""/>
-        <p:cNvGrpSpPr/>
-        <p:nvPr/>
-      </p:nvGrpSpPr>
-      <p:grpSpPr>
-        <a:xfrm>
-          <a:off x="0" y="0"/>
-          <a:ext cx="0" cy="0"/>
-          <a:chOff x="0" y="0"/>
-          <a:chExt cx="0" cy="0"/>
-        </a:xfrm>
-      </p:grpSpPr>
-      <p:sp>
-        <p:nvSpPr>
-          <p:cNvPr id="2" name="CasellaDiTesto 1">
-            <a:extLst>
-              <a:ext uri="{FF2B5EF4-FFF2-40B4-BE49-F238E27FC236}">
-                <a16:creationId xmlns:a16="http://schemas.microsoft.com/office/drawing/2014/main" id="{0D44854F-2D30-FA80-801A-BA45E86EE13F}"/>
-              </a:ext>
-            </a:extLst>
-          </p:cNvPr>
-          <p:cNvSpPr txBox="1"/>
-          <p:nvPr/>
-        </p:nvSpPr>
-        <p:spPr>
-          <a:xfrm>
-            <a:off x="2682240" y="1201783"/>
-            <a:ext cx="184731" cy="369332"/>
-          </a:xfrm>
-          <a:prstGeom prst="rect">
-            <a:avLst/>
-          </a:prstGeom>
-          <a:noFill/>
-        </p:spPr>
-        <p:txBody>
-          <a:bodyPr wrap="none" rtlCol="0">
-            <a:spAutoFit/>
-          </a:bodyPr>
-          <a:lstStyle/>
-          <a:p>
-            <a:endParaRPr lang="it-IT" dirty="0"/>
-          </a:p>
-        </p:txBody>
-      </p:sp>
-      <p:sp>
-        <p:nvSpPr>
-          <p:cNvPr id="4" name="TextBox 3">
-            <a:extLst>
-              <a:ext uri="{FF2B5EF4-FFF2-40B4-BE49-F238E27FC236}">
-                <a16:creationId xmlns:a16="http://schemas.microsoft.com/office/drawing/2014/main" id="{8C45A6E3-2DAE-D404-1AB9-B6309BF05F6A}"/>
-              </a:ext>
-            </a:extLst>
-          </p:cNvPr>
-          <p:cNvSpPr txBox="1"/>
-          <p:nvPr/>
-        </p:nvSpPr>
-        <p:spPr>
-          <a:xfrm>
-            <a:off x="606829" y="426315"/>
-            <a:ext cx="9144000" cy="523220"/>
-          </a:xfrm>
-          <a:prstGeom prst="rect">
-            <a:avLst/>
-          </a:prstGeom>
-          <a:noFill/>
-        </p:spPr>
-        <p:txBody>
-          <a:bodyPr wrap="square" rtlCol="0">
-            <a:spAutoFit/>
-          </a:bodyPr>
-          <a:lstStyle>
-            <a:defPPr>
-              <a:defRPr lang="it-IT"/>
-            </a:defPPr>
-            <a:lvl1pPr>
-              <a:defRPr sz="2800" b="1"/>
-            </a:lvl1pPr>
-          </a:lstStyle>
-          <a:p>
-            <a:pPr algn="l"/>
-            <a:r>
-              <a:rPr lang="en-IT">
-                <a:latin typeface="Calibri" panose="020F0502020204030204" pitchFamily="34" charset="0"/>
-                <a:cs typeface="Calibri" panose="020F0502020204030204" pitchFamily="34" charset="0"/>
-              </a:rPr>
-              <a:t>PROGRAMMA DEL CORSO</a:t>
-            </a:r>
-            <a:r>
-              <a:rPr lang="it-IT" dirty="0">
-                <a:latin typeface="Calibri" panose="020F0502020204030204" pitchFamily="34" charset="0"/>
-                <a:cs typeface="Calibri" panose="020F0502020204030204" pitchFamily="34" charset="0"/>
-              </a:rPr>
-              <a:t> (</a:t>
-            </a:r>
-            <a:r>
-              <a:rPr lang="en-IT">
-                <a:latin typeface="Calibri" panose="020F0502020204030204" pitchFamily="34" charset="0"/>
-                <a:cs typeface="Calibri" panose="020F0502020204030204" pitchFamily="34" charset="0"/>
-              </a:rPr>
-              <a:t>Giorno 1</a:t>
-            </a:r>
-            <a:r>
-              <a:rPr lang="it-IT" dirty="0">
-                <a:latin typeface="Calibri" panose="020F0502020204030204" pitchFamily="34" charset="0"/>
-                <a:cs typeface="Calibri" panose="020F0502020204030204" pitchFamily="34" charset="0"/>
-              </a:rPr>
-              <a:t>)</a:t>
-            </a:r>
-            <a:endParaRPr lang="en-IT">
-              <a:latin typeface="Calibri" panose="020F0502020204030204" pitchFamily="34" charset="0"/>
-              <a:cs typeface="Calibri" panose="020F0502020204030204" pitchFamily="34" charset="0"/>
-            </a:endParaRPr>
-          </a:p>
-        </p:txBody>
-      </p:sp>
-      <p:sp>
-        <p:nvSpPr>
-          <p:cNvPr id="6" name="CasellaDiTesto 1">
-            <a:extLst>
-              <a:ext uri="{FF2B5EF4-FFF2-40B4-BE49-F238E27FC236}">
-                <a16:creationId xmlns:a16="http://schemas.microsoft.com/office/drawing/2014/main" id="{35D6CF70-56AF-A22D-3A00-8DCF34467A4A}"/>
-              </a:ext>
-            </a:extLst>
-          </p:cNvPr>
-          <p:cNvSpPr txBox="1"/>
-          <p:nvPr/>
-        </p:nvSpPr>
-        <p:spPr>
-          <a:xfrm>
-            <a:off x="2682240" y="2470243"/>
-            <a:ext cx="184731" cy="369332"/>
-          </a:xfrm>
-          <a:prstGeom prst="rect">
-            <a:avLst/>
-          </a:prstGeom>
-          <a:noFill/>
-        </p:spPr>
-        <p:txBody>
-          <a:bodyPr wrap="none" rtlCol="0">
-            <a:spAutoFit/>
-          </a:bodyPr>
-          <a:lstStyle/>
-          <a:p>
-            <a:endParaRPr lang="it-IT" dirty="0"/>
-          </a:p>
-        </p:txBody>
-      </p:sp>
-      <p:sp>
-        <p:nvSpPr>
-          <p:cNvPr id="8" name="TextBox 2">
-            <a:extLst>
-              <a:ext uri="{FF2B5EF4-FFF2-40B4-BE49-F238E27FC236}">
-                <a16:creationId xmlns:a16="http://schemas.microsoft.com/office/drawing/2014/main" id="{694ABEB5-4007-7951-0296-A03837E8A214}"/>
-              </a:ext>
-            </a:extLst>
-          </p:cNvPr>
-          <p:cNvSpPr txBox="1"/>
-          <p:nvPr/>
-        </p:nvSpPr>
-        <p:spPr>
-          <a:xfrm>
-            <a:off x="606829" y="1419107"/>
-            <a:ext cx="11363498" cy="5262979"/>
-          </a:xfrm>
-          <a:prstGeom prst="rect">
-            <a:avLst/>
-          </a:prstGeom>
-          <a:noFill/>
-        </p:spPr>
-        <p:txBody>
-          <a:bodyPr wrap="square" rtlCol="0">
-            <a:spAutoFit/>
-          </a:bodyPr>
-          <a:lstStyle/>
-          <a:p>
-            <a:pPr algn="l"/>
-          </a:p>
-          <a:p>
-            <a:pPr algn="l"/>
-            <a:r>
-              <a:rPr sz="2400" b="1">
-                <a:solidFill>
-                  <a:srgbClr val="374151"/>
-                </a:solidFill>
-                <a:latin typeface="Calibri"/>
-                <a:cs typeface="Calibri"/>
-              </a:rPr>
-              <a:t>Blocco 1: Setup, Python e sintassi di base</a:t>
-            </a:r>
-          </a:p>
-          <a:p>
-            <a:pPr algn="l" marL="342900" indent="-342900">
-              <a:buFont typeface="Arial" panose="020B0604020202020204" pitchFamily="34" charset="0"/>
-              <a:buChar char="•"/>
-            </a:pPr>
-            <a:r>
-              <a:rPr sz="2400" b="0">
-                <a:solidFill>
-                  <a:srgbClr val="374151"/>
-                </a:solidFill>
-                <a:latin typeface="Calibri"/>
-                <a:cs typeface="Calibri"/>
-              </a:rPr>
-              <a:t>Ambiente di lavoro: VS Code, uv, notebook e script; cos'è Python, cosa sono le librerie</a:t>
-            </a:r>
-          </a:p>
-          <a:p>
-            <a:pPr algn="l" marL="342900" indent="-342900">
-              <a:buFont typeface="Arial" panose="020B0604020202020204" pitchFamily="34" charset="0"/>
-              <a:buChar char="•"/>
-            </a:pPr>
-            <a:r>
-              <a:rPr sz="2400" b="0">
-                <a:solidFill>
-                  <a:srgbClr val="374151"/>
-                </a:solidFill>
-                <a:latin typeface="Calibri"/>
-                <a:cs typeface="Calibri"/>
-              </a:rPr>
-              <a:t>Sintassi di base: variabili, numeri, stringhe, liste, tuple, dizionari, set</a:t>
-            </a:r>
-          </a:p>
-          <a:p>
-            <a:pPr algn="l" marL="342900" indent="-342900">
-              <a:buFont typeface="Arial" panose="020B0604020202020204" pitchFamily="34" charset="0"/>
-              <a:buChar char="•"/>
-            </a:pPr>
-            <a:r>
-              <a:rPr sz="2400" b="0">
-                <a:solidFill>
-                  <a:srgbClr val="374151"/>
-                </a:solidFill>
-                <a:latin typeface="Calibri"/>
-                <a:cs typeface="Calibri"/>
-              </a:rPr>
-              <a:t>Codice leggibile: commenti, docstring, PEP 8 e Ruff</a:t>
-            </a:r>
-          </a:p>
-          <a:p>
-            <a:pPr algn="l"/>
-            <a:endParaRPr sz="1200" lang="it-IT"/>
-          </a:p>
-          <a:p>
-            <a:pPr algn="l"/>
-            <a:r>
-              <a:rPr sz="2400" b="1">
-                <a:solidFill>
-                  <a:srgbClr val="374151"/>
-                </a:solidFill>
-                <a:latin typeface="Calibri"/>
-                <a:cs typeface="Calibri"/>
-              </a:rPr>
-              <a:t>Blocco 2: Controllo del flusso, funzioni e primi dati in pandas</a:t>
-            </a:r>
-          </a:p>
-          <a:p>
-            <a:pPr algn="l" marL="342900" indent="-342900">
-              <a:buFont typeface="Arial" panose="020B0604020202020204" pitchFamily="34" charset="0"/>
-              <a:buChar char="•"/>
-            </a:pPr>
-            <a:r>
-              <a:rPr sz="2400" b="0">
-                <a:solidFill>
-                  <a:srgbClr val="374151"/>
-                </a:solidFill>
-                <a:latin typeface="Calibri"/>
-                <a:cs typeface="Calibri"/>
-              </a:rPr>
-              <a:t>Condizioni, cicli e funzioni</a:t>
-            </a:r>
-          </a:p>
-          <a:p>
-            <a:pPr algn="l" marL="342900" indent="-342900">
-              <a:buFont typeface="Arial" panose="020B0604020202020204" pitchFamily="34" charset="0"/>
-              <a:buChar char="•"/>
-            </a:pPr>
-            <a:r>
-              <a:rPr sz="2400" b="0">
-                <a:solidFill>
-                  <a:srgbClr val="374151"/>
-                </a:solidFill>
-                <a:latin typeface="Calibri"/>
-                <a:cs typeface="Calibri"/>
-              </a:rPr>
-              <a:t>Oggetti ed errori: attributi, metodi, leggere un traceback</a:t>
-            </a:r>
-          </a:p>
-          <a:p>
-            <a:pPr algn="l" marL="342900" indent="-342900">
-              <a:buFont typeface="Arial" panose="020B0604020202020204" pitchFamily="34" charset="0"/>
-              <a:buChar char="•"/>
-            </a:pPr>
-            <a:r>
-              <a:rPr sz="2400" b="0">
-                <a:solidFill>
-                  <a:srgbClr val="374151"/>
-                </a:solidFill>
-                <a:latin typeface="Calibri"/>
-                <a:cs typeface="Calibri"/>
-              </a:rPr>
-              <a:t>pandas: Series e DataFrame; dati da CSV, Excel, database SQL e API</a:t>
-            </a:r>
-          </a:p>
-          <a:p>
-            <a:pPr algn="l"/>
-            <a:endParaRPr sz="1200" lang="it-IT"/>
-          </a:p>
-          <a:p>
-            <a:pPr algn="l"/>
-            <a:r>
-              <a:rPr sz="2400" b="1">
-                <a:solidFill>
-                  <a:srgbClr val="374151"/>
-                </a:solidFill>
-                <a:latin typeface="Calibri"/>
-                <a:cs typeface="Calibri"/>
-              </a:rPr>
-              <a:t>Homework tra le due giornate</a:t>
-            </a:r>
-            <a:r>
-              <a:rPr sz="2400" b="0">
-                <a:solidFill>
-                  <a:srgbClr val="374151"/>
-                </a:solidFill>
-                <a:latin typeface="Calibri"/>
-                <a:cs typeface="Calibri"/>
-              </a:rPr>
-              <a:t>: una settimana nell'ufficio Analisi Consumi</a:t>
-            </a:r>
-          </a:p>
-        </p:txBody>
-      </p:sp>
-    </p:spTree>
-    <p:extLst>
-      <p:ext uri="{BB962C8B-B14F-4D97-AF65-F5344CB8AC3E}">
-        <p14:creationId xmlns:p14="http://schemas.microsoft.com/office/powerpoint/2010/main" val="45302024"/>
-      </p:ext>
-    </p:extLst>
-  </p:cSld>
-  <p:clrMapOvr>
-    <a:masterClrMapping/>
-  </p:clrMapOvr>
-</p:sld>
-</file>
-
-<file path=ppt/slides/slide22.xml><?xml version="1.0" encoding="utf-8"?>
+<file path=ppt/slides/slide17.xml><?xml version="1.0" encoding="utf-8"?>
 <p:sld xmlns:a="http://schemas.openxmlformats.org/drawingml/2006/main" xmlns:r="http://schemas.openxmlformats.org/officeDocument/2006/relationships" xmlns:p="http://schemas.openxmlformats.org/presentationml/2006/main">
   <p:cSld>
     <p:spTree>
@@ -10448,6 +10098,356 @@
 </p:sld>
 </file>
 
+<file path=ppt/slides/slide2.xml><?xml version="1.0" encoding="utf-8"?>
+<p:sld xmlns:a="http://schemas.openxmlformats.org/drawingml/2006/main" xmlns:r="http://schemas.openxmlformats.org/officeDocument/2006/relationships" xmlns:p="http://schemas.openxmlformats.org/presentationml/2006/main">
+  <p:cSld>
+    <p:spTree>
+      <p:nvGrpSpPr>
+        <p:cNvPr id="1" name=""/>
+        <p:cNvGrpSpPr/>
+        <p:nvPr/>
+      </p:nvGrpSpPr>
+      <p:grpSpPr>
+        <a:xfrm>
+          <a:off x="0" y="0"/>
+          <a:ext cx="0" cy="0"/>
+          <a:chOff x="0" y="0"/>
+          <a:chExt cx="0" cy="0"/>
+        </a:xfrm>
+      </p:grpSpPr>
+      <p:sp>
+        <p:nvSpPr>
+          <p:cNvPr id="2" name="CasellaDiTesto 1">
+            <a:extLst>
+              <a:ext uri="{FF2B5EF4-FFF2-40B4-BE49-F238E27FC236}">
+                <a16:creationId xmlns:a16="http://schemas.microsoft.com/office/drawing/2014/main" id="{0D44854F-2D30-FA80-801A-BA45E86EE13F}"/>
+              </a:ext>
+            </a:extLst>
+          </p:cNvPr>
+          <p:cNvSpPr txBox="1"/>
+          <p:nvPr/>
+        </p:nvSpPr>
+        <p:spPr>
+          <a:xfrm>
+            <a:off x="2682240" y="1201783"/>
+            <a:ext cx="184731" cy="369332"/>
+          </a:xfrm>
+          <a:prstGeom prst="rect">
+            <a:avLst/>
+          </a:prstGeom>
+          <a:noFill/>
+        </p:spPr>
+        <p:txBody>
+          <a:bodyPr wrap="none" rtlCol="0">
+            <a:spAutoFit/>
+          </a:bodyPr>
+          <a:lstStyle/>
+          <a:p>
+            <a:endParaRPr lang="it-IT" dirty="0"/>
+          </a:p>
+        </p:txBody>
+      </p:sp>
+      <p:sp>
+        <p:nvSpPr>
+          <p:cNvPr id="4" name="TextBox 3">
+            <a:extLst>
+              <a:ext uri="{FF2B5EF4-FFF2-40B4-BE49-F238E27FC236}">
+                <a16:creationId xmlns:a16="http://schemas.microsoft.com/office/drawing/2014/main" id="{8C45A6E3-2DAE-D404-1AB9-B6309BF05F6A}"/>
+              </a:ext>
+            </a:extLst>
+          </p:cNvPr>
+          <p:cNvSpPr txBox="1"/>
+          <p:nvPr/>
+        </p:nvSpPr>
+        <p:spPr>
+          <a:xfrm>
+            <a:off x="606829" y="426315"/>
+            <a:ext cx="9144000" cy="523220"/>
+          </a:xfrm>
+          <a:prstGeom prst="rect">
+            <a:avLst/>
+          </a:prstGeom>
+          <a:noFill/>
+        </p:spPr>
+        <p:txBody>
+          <a:bodyPr wrap="square" rtlCol="0">
+            <a:spAutoFit/>
+          </a:bodyPr>
+          <a:lstStyle>
+            <a:defPPr>
+              <a:defRPr lang="it-IT"/>
+            </a:defPPr>
+            <a:lvl1pPr>
+              <a:defRPr sz="2800" b="1"/>
+            </a:lvl1pPr>
+          </a:lstStyle>
+          <a:p>
+            <a:pPr algn="l"/>
+            <a:r>
+              <a:rPr lang="en-IT">
+                <a:latin typeface="Calibri" panose="020F0502020204030204" pitchFamily="34" charset="0"/>
+                <a:cs typeface="Calibri" panose="020F0502020204030204" pitchFamily="34" charset="0"/>
+              </a:rPr>
+              <a:t>PROGRAMMA DEL CORSO</a:t>
+            </a:r>
+            <a:r>
+              <a:rPr lang="it-IT" dirty="0">
+                <a:latin typeface="Calibri" panose="020F0502020204030204" pitchFamily="34" charset="0"/>
+                <a:cs typeface="Calibri" panose="020F0502020204030204" pitchFamily="34" charset="0"/>
+              </a:rPr>
+              <a:t> (</a:t>
+            </a:r>
+            <a:r>
+              <a:rPr lang="en-IT">
+                <a:latin typeface="Calibri" panose="020F0502020204030204" pitchFamily="34" charset="0"/>
+                <a:cs typeface="Calibri" panose="020F0502020204030204" pitchFamily="34" charset="0"/>
+              </a:rPr>
+              <a:t>Giorno 1</a:t>
+            </a:r>
+            <a:r>
+              <a:rPr lang="it-IT" dirty="0">
+                <a:latin typeface="Calibri" panose="020F0502020204030204" pitchFamily="34" charset="0"/>
+                <a:cs typeface="Calibri" panose="020F0502020204030204" pitchFamily="34" charset="0"/>
+              </a:rPr>
+              <a:t>)</a:t>
+            </a:r>
+            <a:endParaRPr lang="en-IT">
+              <a:latin typeface="Calibri" panose="020F0502020204030204" pitchFamily="34" charset="0"/>
+              <a:cs typeface="Calibri" panose="020F0502020204030204" pitchFamily="34" charset="0"/>
+            </a:endParaRPr>
+          </a:p>
+        </p:txBody>
+      </p:sp>
+      <p:sp>
+        <p:nvSpPr>
+          <p:cNvPr id="6" name="CasellaDiTesto 1">
+            <a:extLst>
+              <a:ext uri="{FF2B5EF4-FFF2-40B4-BE49-F238E27FC236}">
+                <a16:creationId xmlns:a16="http://schemas.microsoft.com/office/drawing/2014/main" id="{35D6CF70-56AF-A22D-3A00-8DCF34467A4A}"/>
+              </a:ext>
+            </a:extLst>
+          </p:cNvPr>
+          <p:cNvSpPr txBox="1"/>
+          <p:nvPr/>
+        </p:nvSpPr>
+        <p:spPr>
+          <a:xfrm>
+            <a:off x="2682240" y="2470243"/>
+            <a:ext cx="184731" cy="369332"/>
+          </a:xfrm>
+          <a:prstGeom prst="rect">
+            <a:avLst/>
+          </a:prstGeom>
+          <a:noFill/>
+        </p:spPr>
+        <p:txBody>
+          <a:bodyPr wrap="none" rtlCol="0">
+            <a:spAutoFit/>
+          </a:bodyPr>
+          <a:lstStyle/>
+          <a:p>
+            <a:endParaRPr lang="it-IT" dirty="0"/>
+          </a:p>
+        </p:txBody>
+      </p:sp>
+      <p:sp>
+        <p:nvSpPr>
+          <p:cNvPr id="8" name="TextBox 2">
+            <a:extLst>
+              <a:ext uri="{FF2B5EF4-FFF2-40B4-BE49-F238E27FC236}">
+                <a16:creationId xmlns:a16="http://schemas.microsoft.com/office/drawing/2014/main" id="{694ABEB5-4007-7951-0296-A03837E8A214}"/>
+              </a:ext>
+            </a:extLst>
+          </p:cNvPr>
+          <p:cNvSpPr txBox="1"/>
+          <p:nvPr/>
+        </p:nvSpPr>
+        <p:spPr>
+          <a:xfrm>
+            <a:off x="606829" y="1419107"/>
+            <a:ext cx="11363498" cy="5262979"/>
+          </a:xfrm>
+          <a:prstGeom prst="rect">
+            <a:avLst/>
+          </a:prstGeom>
+          <a:noFill/>
+        </p:spPr>
+        <p:txBody>
+          <a:bodyPr wrap="square" rtlCol="0">
+            <a:spAutoFit/>
+          </a:bodyPr>
+          <a:lstStyle/>
+          <a:p>
+            <a:pPr algn="l"/>
+          </a:p>
+          <a:p>
+            <a:pPr algn="l"/>
+            <a:r>
+              <a:rPr sz="2400" b="1">
+                <a:solidFill>
+                  <a:srgbClr val="374151"/>
+                </a:solidFill>
+                <a:latin typeface="Calibri"/>
+                <a:cs typeface="Calibri"/>
+              </a:rPr>
+              <a:t>Blocco 1: Setup, Python e sintassi di base</a:t>
+            </a:r>
+          </a:p>
+          <a:p>
+            <a:pPr algn="l" marL="342900" indent="-342900">
+              <a:buFont typeface="Arial" panose="020B0604020202020204" pitchFamily="34" charset="0"/>
+              <a:buChar char="•"/>
+            </a:pPr>
+            <a:r>
+              <a:rPr sz="2400" b="0">
+                <a:solidFill>
+                  <a:srgbClr val="374151"/>
+                </a:solidFill>
+                <a:latin typeface="Calibri"/>
+                <a:cs typeface="Calibri"/>
+              </a:rPr>
+              <a:t>Ambiente di lavoro: VS Code, uv, notebook e script; cos'è Python, cosa sono le librerie</a:t>
+            </a:r>
+          </a:p>
+          <a:p>
+            <a:pPr algn="l" marL="342900" indent="-342900">
+              <a:buFont typeface="Arial" panose="020B0604020202020204" pitchFamily="34" charset="0"/>
+              <a:buChar char="•"/>
+            </a:pPr>
+            <a:r>
+              <a:rPr sz="2400" b="0">
+                <a:solidFill>
+                  <a:srgbClr val="374151"/>
+                </a:solidFill>
+                <a:latin typeface="Calibri"/>
+                <a:cs typeface="Calibri"/>
+              </a:rPr>
+              <a:t>Sintassi di base: variabili, numeri, stringhe, liste, tuple, dizionari, set</a:t>
+            </a:r>
+          </a:p>
+          <a:p>
+            <a:pPr algn="l" marL="342900" indent="-342900">
+              <a:buFont typeface="Arial" panose="020B0604020202020204" pitchFamily="34" charset="0"/>
+              <a:buChar char="•"/>
+            </a:pPr>
+            <a:r>
+              <a:rPr sz="2400" b="0">
+                <a:solidFill>
+                  <a:srgbClr val="374151"/>
+                </a:solidFill>
+                <a:latin typeface="Calibri"/>
+                <a:cs typeface="Calibri"/>
+              </a:rPr>
+              <a:t>Codice leggibile: commenti, docstring, PEP 8</a:t>
+            </a:r>
+          </a:p>
+          <a:p>
+            <a:pPr algn="l"/>
+            <a:endParaRPr sz="1200" lang="it-IT"/>
+          </a:p>
+          <a:p>
+            <a:pPr algn="l"/>
+            <a:r>
+              <a:rPr sz="2400" b="1">
+                <a:solidFill>
+                  <a:srgbClr val="374151"/>
+                </a:solidFill>
+                <a:latin typeface="Calibri"/>
+                <a:cs typeface="Calibri"/>
+              </a:rPr>
+              <a:t>Blocco 2: Controllo del flusso, funzioni e primi dati in pandas</a:t>
+            </a:r>
+          </a:p>
+          <a:p>
+            <a:pPr algn="l" marL="342900" indent="-342900">
+              <a:buFont typeface="Arial" panose="020B0604020202020204" pitchFamily="34" charset="0"/>
+              <a:buChar char="•"/>
+            </a:pPr>
+            <a:r>
+              <a:rPr sz="2400" b="0">
+                <a:solidFill>
+                  <a:srgbClr val="374151"/>
+                </a:solidFill>
+                <a:latin typeface="Calibri"/>
+                <a:cs typeface="Calibri"/>
+              </a:rPr>
+              <a:t>Condizioni, cicli e funzioni</a:t>
+            </a:r>
+          </a:p>
+          <a:p>
+            <a:pPr algn="l" marL="342900" indent="-342900">
+              <a:buFont typeface="Arial" panose="020B0604020202020204" pitchFamily="34" charset="0"/>
+              <a:buChar char="•"/>
+            </a:pPr>
+            <a:r>
+              <a:rPr sz="2400" b="0">
+                <a:solidFill>
+                  <a:srgbClr val="374151"/>
+                </a:solidFill>
+                <a:latin typeface="Calibri"/>
+                <a:cs typeface="Calibri"/>
+              </a:rPr>
+              <a:t>Oggetti ed errori: attributi, metodi, leggere un traceback</a:t>
+            </a:r>
+          </a:p>
+          <a:p>
+            <a:pPr algn="l" marL="342900" indent="-342900">
+              <a:buFont typeface="Arial" panose="020B0604020202020204" pitchFamily="34" charset="0"/>
+              <a:buChar char="•"/>
+            </a:pPr>
+            <a:r>
+              <a:rPr sz="2400" b="0">
+                <a:solidFill>
+                  <a:srgbClr val="374151"/>
+                </a:solidFill>
+                <a:latin typeface="Calibri"/>
+                <a:cs typeface="Calibri"/>
+              </a:rPr>
+              <a:t>pandas: Series e DataFrame; dati da CSV, Excel, database SQL e API</a:t>
+            </a:r>
+          </a:p>
+          <a:p>
+            <a:pPr algn="l"/>
+            <a:endParaRPr sz="1200" lang="it-IT"/>
+          </a:p>
+          <a:p>
+            <a:pPr algn="l"/>
+            <a:r>
+              <a:rPr sz="2400" b="1">
+                <a:solidFill>
+                  <a:srgbClr val="374151"/>
+                </a:solidFill>
+                <a:latin typeface="Calibri"/>
+                <a:cs typeface="Calibri"/>
+              </a:rPr>
+              <a:t>Homework tra le due giornate</a:t>
+            </a:r>
+            <a:r>
+              <a:rPr sz="2400" b="0">
+                <a:solidFill>
+                  <a:srgbClr val="374151"/>
+                </a:solidFill>
+                <a:latin typeface="Calibri"/>
+                <a:cs typeface="Calibri"/>
+              </a:rPr>
+              <a:t>: una settimana nell'ufficio Analisi Consumi</a:t>
+            </a:r>
+          </a:p>
+        </p:txBody>
+      </p:sp>
+    </p:spTree>
+    <p:extLst>
+      <p:ext uri="{BB962C8B-B14F-4D97-AF65-F5344CB8AC3E}">
+        <p14:creationId xmlns:p14="http://schemas.microsoft.com/office/powerpoint/2010/main" val="45302024"/>
+      </p:ext>
+    </p:extLst>
+  </p:cSld>
+  <p:clrMapOvr>
+    <a:masterClrMapping/>
+  </p:clrMapOvr>
+</p:sld>
+</file>
+
 <file path=ppt/slides/slide3.xml><?xml version="1.0" encoding="utf-8"?>
 <p:sld xmlns:a="http://schemas.openxmlformats.org/drawingml/2006/main" xmlns:r="http://schemas.openxmlformats.org/officeDocument/2006/relationships" xmlns:p="http://schemas.openxmlformats.org/presentationml/2006/main">
   <p:cSld>
@@ -10734,7 +10734,7 @@
                 <a:latin typeface="Calibri"/>
                 <a:cs typeface="Calibri"/>
               </a:rPr>
-              <a:t>Leggere il codice scritto da un agente: import, costanti, funzioni, main</a:t>
+              <a:t>Leggere il codice scritto da un agente: import, costanti, funzioni, main; controllo con Ruff</a:t>
             </a:r>
           </a:p>
           <a:p>

</xml_diff>

<commit_message>
Snapshot: versione semplificata in corso (01, E1, Extra pronti)
Co-Authored-By: Claude Fable 5.1 <noreply@anthropic.com>
Claude-Session: https://claude.ai/code/session_01P1BQsLkuhRse3RJB6S6MwQ
</commit_message>
<xml_diff>
--- a/Slides/Presentazione_python_base.pptx
+++ b/Slides/Presentazione_python_base.pptx
@@ -9318,7 +9318,7 @@
                 <a:latin typeface="Calibri"/>
                 <a:cs typeface="Calibri"/>
               </a:rPr>
-              <a:t>: import, costanti, def, main; decoratori e type hint si riconoscono, non si scrivono</a:t>
+              <a:t>: import, costanti, def, main; decoratori e type hint si riconoscono</a:t>
             </a:r>
           </a:p>
         </p:txBody>
@@ -10306,7 +10306,7 @@
                 <a:latin typeface="Calibri"/>
                 <a:cs typeface="Calibri"/>
               </a:rPr>
-              <a:t>Ambiente di lavoro: VS Code, uv, notebook e script; cos'è Python, cosa sono le librerie</a:t>
+              <a:t>Jupyter e i notebook; Python: variabili, numeri, stringhe, import</a:t>
             </a:r>
           </a:p>
           <a:p>
@@ -10322,7 +10322,7 @@
                 <a:latin typeface="Calibri"/>
                 <a:cs typeface="Calibri"/>
               </a:rPr>
-              <a:t>Sintassi di base: variabili, numeri, stringhe, liste, tuple, dizionari, set</a:t>
+              <a:t>Tipi di dato: liste, tuple, dizionari, set</a:t>
             </a:r>
           </a:p>
           <a:p>
@@ -10342,23 +10342,6 @@
             </a:r>
           </a:p>
           <a:p>
-            <a:pPr algn="l"/>
-            <a:endParaRPr sz="1200" lang="it-IT"/>
-          </a:p>
-          <a:p>
-            <a:pPr algn="l"/>
-            <a:r>
-              <a:rPr sz="2400" b="1">
-                <a:solidFill>
-                  <a:srgbClr val="374151"/>
-                </a:solidFill>
-                <a:latin typeface="Calibri"/>
-                <a:cs typeface="Calibri"/>
-              </a:rPr>
-              <a:t>Blocco 2: Controllo del flusso, funzioni e primi dati in pandas</a:t>
-            </a:r>
-          </a:p>
-          <a:p>
             <a:pPr algn="l" marL="342900" indent="-342900">
               <a:buFont typeface="Arial" panose="020B0604020202020204" pitchFamily="34" charset="0"/>
               <a:buChar char="•"/>
@@ -10371,7 +10354,24 @@
                 <a:latin typeface="Calibri"/>
                 <a:cs typeface="Calibri"/>
               </a:rPr>
-              <a:t>Condizioni, cicli e funzioni</a:t>
+              <a:t>Esercitazione 1</a:t>
+            </a:r>
+          </a:p>
+          <a:p>
+            <a:pPr algn="l"/>
+            <a:endParaRPr sz="1200" lang="it-IT"/>
+          </a:p>
+          <a:p>
+            <a:pPr algn="l"/>
+            <a:r>
+              <a:rPr sz="2400" b="1">
+                <a:solidFill>
+                  <a:srgbClr val="374151"/>
+                </a:solidFill>
+                <a:latin typeface="Calibri"/>
+                <a:cs typeface="Calibri"/>
+              </a:rPr>
+              <a:t>Blocco 2: Controllo del flusso, funzioni e primi dati in pandas</a:t>
             </a:r>
           </a:p>
           <a:p>
@@ -10387,7 +10387,7 @@
                 <a:latin typeface="Calibri"/>
                 <a:cs typeface="Calibri"/>
               </a:rPr>
-              <a:t>Oggetti ed errori: attributi, metodi, leggere un traceback</a:t>
+              <a:t>Funzioni e controllo del flusso (Avanzata: lambda, comprehension, generatori)</a:t>
             </a:r>
           </a:p>
           <a:p>
@@ -10403,7 +10403,39 @@
                 <a:latin typeface="Calibri"/>
                 <a:cs typeface="Calibri"/>
               </a:rPr>
-              <a:t>pandas: Series e DataFrame; dati da CSV, Excel, database SQL e API</a:t>
+              <a:t>Oggetti ed errori: attributi, metodi, leggere un traceback</a:t>
+            </a:r>
+          </a:p>
+          <a:p>
+            <a:pPr algn="l" marL="342900" indent="-342900">
+              <a:buFont typeface="Arial" panose="020B0604020202020204" pitchFamily="34" charset="0"/>
+              <a:buChar char="•"/>
+            </a:pPr>
+            <a:r>
+              <a:rPr sz="2400" b="0">
+                <a:solidFill>
+                  <a:srgbClr val="374151"/>
+                </a:solidFill>
+                <a:latin typeface="Calibri"/>
+                <a:cs typeface="Calibri"/>
+              </a:rPr>
+              <a:t>pandas: Series e DataFrame; dati da CSV, Excel, database SQL (Avanzata: API)</a:t>
+            </a:r>
+          </a:p>
+          <a:p>
+            <a:pPr algn="l" marL="342900" indent="-342900">
+              <a:buFont typeface="Arial" panose="020B0604020202020204" pitchFamily="34" charset="0"/>
+              <a:buChar char="•"/>
+            </a:pPr>
+            <a:r>
+              <a:rPr sz="2400" b="0">
+                <a:solidFill>
+                  <a:srgbClr val="374151"/>
+                </a:solidFill>
+                <a:latin typeface="Calibri"/>
+                <a:cs typeface="Calibri"/>
+              </a:rPr>
+              <a:t>Esercitazione 2</a:t>
             </a:r>
           </a:p>
           <a:p>
@@ -10653,7 +10685,7 @@
                 <a:latin typeface="Calibri"/>
                 <a:cs typeface="Calibri"/>
               </a:rPr>
-              <a:t>Esplorare con Data Wrangler e leggere il codice pandas che genera</a:t>
+              <a:t>Dati temporali: conversione, indice, resample, ora legale (Avanzata: shift, rolling)</a:t>
             </a:r>
           </a:p>
           <a:p>
@@ -10669,7 +10701,7 @@
                 <a:latin typeface="Calibri"/>
                 <a:cs typeface="Calibri"/>
               </a:rPr>
-              <a:t>Dati temporali: conversione, frequenza, fuso orario e ora legale</a:t>
+              <a:t>Grafici interattivi con Plotly: linee, confronto tra serie, slider</a:t>
             </a:r>
           </a:p>
           <a:p>
@@ -10685,7 +10717,7 @@
                 <a:latin typeface="Calibri"/>
                 <a:cs typeface="Calibri"/>
               </a:rPr>
-              <a:t>Grafici interattivi con Plotly: linee, istogrammi, scatter</a:t>
+              <a:t>Esercitazione 3</a:t>
             </a:r>
           </a:p>
           <a:p>
@@ -10734,7 +10766,7 @@
                 <a:latin typeface="Calibri"/>
                 <a:cs typeface="Calibri"/>
               </a:rPr>
-              <a:t>Leggere il codice scritto da un agente: import, costanti, funzioni, main; controllo con Ruff</a:t>
+              <a:t>Leggere il codice scritto da un agente: import, costanti, funzioni, main</a:t>
             </a:r>
           </a:p>
           <a:p>
@@ -10936,7 +10968,7 @@
                 <a:latin typeface="Calibri" panose="020F0502020204030204" pitchFamily="34" charset="0"/>
                 <a:cs typeface="Calibri" panose="020F0502020204030204" pitchFamily="34" charset="0"/>
               </a:rPr>
-              <a:t>Si scrive molto codice a mano perché è il modo più rapido per imparare a leggerlo.</a:t>
+              <a:t>Si scrive codice a mano, in piccolo, per imparare a leggerlo.</a:t>
             </a:r>
           </a:p>
           <a:p>
@@ -11172,7 +11204,7 @@
                 <a:latin typeface="Calibri" panose="020F0502020204030204" pitchFamily="34" charset="0"/>
                 <a:cs typeface="Calibri" panose="020F0502020204030204" pitchFamily="34" charset="0"/>
               </a:rPr>
-              <a:t>1. È LA LINGUA DEGLI AGENTI</a:t>
+              <a:t>1. È la lingua degli agenti</a:t>
             </a:r>
           </a:p>
           <a:p>
@@ -11211,7 +11243,7 @@
                 <a:latin typeface="Calibri" panose="020F0502020204030204" pitchFamily="34" charset="0"/>
                 <a:cs typeface="Calibri" panose="020F0502020204030204" pitchFamily="34" charset="0"/>
               </a:rPr>
-              <a:t>2. LE LIBRERIE FANNO IL LAVORO</a:t>
+              <a:t>2. Le librerie fanno il lavoro</a:t>
             </a:r>
           </a:p>
           <a:p>
@@ -11250,7 +11282,7 @@
                 <a:latin typeface="Calibri" panose="020F0502020204030204" pitchFamily="34" charset="0"/>
                 <a:cs typeface="Calibri" panose="020F0502020204030204" pitchFamily="34" charset="0"/>
               </a:rPr>
-              <a:t>3. LEGGERE È LA COMPETENZA CHE RESTA</a:t>
+              <a:t>3. Leggere è la competenza che resta</a:t>
             </a:r>
           </a:p>
           <a:p>

</xml_diff>

<commit_message>
Correzioni dal controllo di coerenza: esempio nel 10, guida e README, docstring del toolkit, slide del capstone a sei passi
Co-Authored-By: Claude Fable 5.1 <noreply@anthropic.com>
Claude-Session: https://claude.ai/code/session_01P1BQsLkuhRse3RJB6S6MwQ
</commit_message>
<xml_diff>
--- a/Slides/Presentazione_python_base.pptx
+++ b/Slides/Presentazione_python_base.pptx
@@ -9938,7 +9938,7 @@
                 <a:latin typeface="Calibri"/>
                 <a:cs typeface="Calibri"/>
               </a:rPr>
-              <a:t>1. Caricare e unire i dati Terna 2024 e 2025: zona Nord, quartorari</a:t>
+              <a:t>1. Caricamento e unione dei dati Terna 2024 e 2025: zona Nord, quartorari</a:t>
             </a:r>
           </a:p>
           <a:p>
@@ -9953,7 +9953,7 @@
                 <a:latin typeface="Calibri"/>
                 <a:cs typeface="Calibri"/>
               </a:rPr>
-              <a:t>2. Pulizia temporale: ordinare, togliere i duplicati dell'ora legale, contare i buchi</a:t>
+              <a:t>2. Colonna temporale e prima visualizzazione; via le colonne che non servono</a:t>
             </a:r>
           </a:p>
           <a:p>
@@ -9968,7 +9968,7 @@
                 <a:latin typeface="Calibri"/>
                 <a:cs typeface="Calibri"/>
               </a:rPr>
-              <a:t>3. Serie giornaliera: da MW quartorari a MWh al giorno</a:t>
+              <a:t>3. Ora legale: i duplicati di ottobre e i buchi di marzo</a:t>
             </a:r>
           </a:p>
           <a:p>
@@ -9983,7 +9983,7 @@
                 <a:latin typeface="Calibri"/>
                 <a:cs typeface="Calibri"/>
               </a:rPr>
-              <a:t>4. Profili medi: per ora del giorno e per giorno della settimana</a:t>
+              <a:t>4. Serie giornaliera e profili medi per ora e per giorno della settimana</a:t>
             </a:r>
           </a:p>
           <a:p>
@@ -10013,22 +10013,7 @@
                 <a:latin typeface="Calibri"/>
                 <a:cs typeface="Calibri"/>
               </a:rPr>
-              <a:t>6. Unione: carico e temperatura sulla stessa riga, giorno per giorno</a:t>
-            </a:r>
-          </a:p>
-          <a:p>
-            <a:pPr algn="l" marL="342900" indent="-342900">
-              <a:buNone/>
-            </a:pPr>
-            <a:r>
-              <a:rPr sz="2000" b="0">
-                <a:solidFill>
-                  <a:srgbClr val="374151"/>
-                </a:solidFill>
-                <a:latin typeface="Calibri"/>
-                <a:cs typeface="Calibri"/>
-              </a:rPr>
-              <a:t>7. Relazione carico-temperatura: scatter con Plotly e sintesi in tre righe per il capo</a:t>
+              <a:t>6. Carico e temperatura: scatter con Plotly e cinque frasi di conclusione</a:t>
             </a:r>
           </a:p>
           <a:p>

</xml_diff>

<commit_message>
Quattro moduli: tempi dei notebook, README, Guida docente, piano e slide aggiornati
Co-Authored-By: Claude Fable 5.1 <noreply@anthropic.com>
Claude-Session: https://claude.ai/code/session_01P1BQsLkuhRse3RJB6S6MwQ
</commit_message>
<xml_diff>
--- a/Slides/Presentazione_python_base.pptx
+++ b/Slides/Presentazione_python_base.pptx
@@ -6898,7 +6898,7 @@
                 <a:ea typeface="Lato" panose="020F0502020204030203" pitchFamily="34" charset="0"/>
                 <a:cs typeface="Lato" panose="020F0502020204030203" pitchFamily="34" charset="0"/>
               </a:rPr>
-              <a:t>23, 30 Gennaio, 2026</a:t>
+              <a:t>20-21 e 27-28 ottobre 2026</a:t>
             </a:r>
           </a:p>
         </p:txBody>
@@ -10173,28 +10173,7 @@
                 <a:latin typeface="Calibri" panose="020F0502020204030204" pitchFamily="34" charset="0"/>
                 <a:cs typeface="Calibri" panose="020F0502020204030204" pitchFamily="34" charset="0"/>
               </a:rPr>
-              <a:t>PROGRAMMA DEL CORSO</a:t>
-            </a:r>
-            <a:r>
-              <a:rPr lang="it-IT" dirty="0">
-                <a:latin typeface="Calibri" panose="020F0502020204030204" pitchFamily="34" charset="0"/>
-                <a:cs typeface="Calibri" panose="020F0502020204030204" pitchFamily="34" charset="0"/>
-              </a:rPr>
-              <a:t> (</a:t>
-            </a:r>
-            <a:r>
-              <a:rPr lang="en-IT">
-                <a:latin typeface="Calibri" panose="020F0502020204030204" pitchFamily="34" charset="0"/>
-                <a:cs typeface="Calibri" panose="020F0502020204030204" pitchFamily="34" charset="0"/>
-              </a:rPr>
-              <a:t>Giorno 1</a:t>
-            </a:r>
-            <a:r>
-              <a:rPr lang="it-IT" dirty="0">
-                <a:latin typeface="Calibri" panose="020F0502020204030204" pitchFamily="34" charset="0"/>
-                <a:cs typeface="Calibri" panose="020F0502020204030204" pitchFamily="34" charset="0"/>
-              </a:rPr>
-              <a:t>)</a:t>
+              <a:t>PROGRAMMA DEL CORSO (Moduli 1 e 2)</a:t>
             </a:r>
             <a:endParaRPr lang="en-IT">
               <a:latin typeface="Calibri" panose="020F0502020204030204" pitchFamily="34" charset="0"/>
@@ -10275,7 +10254,7 @@
                 <a:latin typeface="Calibri"/>
                 <a:cs typeface="Calibri"/>
               </a:rPr>
-              <a:t>Blocco 1: Setup, Python e sintassi di base</a:t>
+              <a:t>Modulo 1 · 20 ottobre · Setup, Python e sintassi di base</a:t>
             </a:r>
           </a:p>
           <a:p>
@@ -10323,7 +10302,7 @@
                 <a:latin typeface="Calibri"/>
                 <a:cs typeface="Calibri"/>
               </a:rPr>
-              <a:t>Codice leggibile: commenti, docstring, PEP 8</a:t>
+              <a:t>Codice leggibile: commenti, docstring, PEP 8 (Avanzata: ambiente uv, script e Ruff)</a:t>
             </a:r>
           </a:p>
           <a:p>
@@ -10356,7 +10335,7 @@
                 <a:latin typeface="Calibri"/>
                 <a:cs typeface="Calibri"/>
               </a:rPr>
-              <a:t>Blocco 2: Controllo del flusso, funzioni e primi dati in pandas</a:t>
+              <a:t>Modulo 2 · 21 ottobre · Controllo del flusso, funzioni e primi dati in pandas</a:t>
             </a:r>
           </a:p>
           <a:p>
@@ -10372,7 +10351,7 @@
                 <a:latin typeface="Calibri"/>
                 <a:cs typeface="Calibri"/>
               </a:rPr>
-              <a:t>Funzioni e controllo del flusso (Avanzata: lambda, comprehension, generatori)</a:t>
+              <a:t>Funzioni e controllo del flusso (Avanzata: lambda, list comprehension)</a:t>
             </a:r>
           </a:p>
           <a:p>
@@ -10437,17 +10416,7 @@
                 <a:latin typeface="Calibri"/>
                 <a:cs typeface="Calibri"/>
               </a:rPr>
-              <a:t>Homework tra le due giornate</a:t>
-            </a:r>
-            <a:r>
-              <a:rPr sz="2400" b="0">
-                <a:solidFill>
-                  <a:srgbClr val="374151"/>
-                </a:solidFill>
-                <a:latin typeface="Calibri"/>
-                <a:cs typeface="Calibri"/>
-              </a:rPr>
-              <a:t>: una settimana nell'ufficio Analisi Consumi</a:t>
+              <a:t>Ogni giornata: aula Base nelle prime quattro ore, aula Avanzata nelle quattro successive</a:t>
             </a:r>
           </a:p>
         </p:txBody>
@@ -10555,15 +10524,7 @@
             <a:pPr algn="l"/>
             <a:r>
               <a:rPr lang="en-IT"/>
-              <a:t>PROGRAMMA DEL CORSO</a:t>
-            </a:r>
-            <a:r>
-              <a:rPr lang="it-IT" dirty="0"/>
-              <a:t> (Giorno </a:t>
-            </a:r>
-            <a:r>
-              <a:rPr lang="it-IT"/>
-              <a:t>2)</a:t>
+              <a:t>PROGRAMMA DEL CORSO (Moduli 3 e 4)</a:t>
             </a:r>
             <a:endParaRPr lang="en-IT" dirty="0"/>
           </a:p>
@@ -10638,7 +10599,7 @@
                 <a:latin typeface="Calibri"/>
                 <a:cs typeface="Calibri"/>
               </a:rPr>
-              <a:t>Blocco 3: Analisi dei dati con pandas e visualizzazione</a:t>
+              <a:t>Modulo 3 · 27 ottobre · Analisi dei dati con pandas</a:t>
             </a:r>
           </a:p>
           <a:p>
@@ -10670,7 +10631,7 @@
                 <a:latin typeface="Calibri"/>
                 <a:cs typeface="Calibri"/>
               </a:rPr>
-              <a:t>Dati temporali: conversione, indice, resample, ora legale (Avanzata: shift, rolling)</a:t>
+              <a:t>Dati temporali: conversione, indice, resample, ora legale</a:t>
             </a:r>
           </a:p>
           <a:p>
@@ -10686,7 +10647,7 @@
                 <a:latin typeface="Calibri"/>
                 <a:cs typeface="Calibri"/>
               </a:rPr>
-              <a:t>Grafici interattivi con Plotly: linee, confronto tra serie, slider</a:t>
+              <a:t>Data Wrangler: esplorare e pulire i dati, leggendo il codice pandas che genera</a:t>
             </a:r>
           </a:p>
           <a:p>
@@ -10719,7 +10680,7 @@
                 <a:latin typeface="Calibri"/>
                 <a:cs typeface="Calibri"/>
               </a:rPr>
-              <a:t>Blocco 4: Agenti per il coding e capstone</a:t>
+              <a:t>Modulo 4 · 28 ottobre · Agenti per il coding e capstone</a:t>
             </a:r>
           </a:p>
           <a:p>
@@ -10735,7 +10696,7 @@
                 <a:latin typeface="Calibri"/>
                 <a:cs typeface="Calibri"/>
               </a:rPr>
-              <a:t>Copilot in VS Code: token, finestra di contesto, modelli, plan e agent</a:t>
+              <a:t>Grafici interattivi con Plotly: linee, confronto tra serie, slider, export HTML</a:t>
             </a:r>
           </a:p>
           <a:p>
@@ -10751,7 +10712,7 @@
                 <a:latin typeface="Calibri"/>
                 <a:cs typeface="Calibri"/>
               </a:rPr>
-              <a:t>Leggere il codice scritto da un agente: import, costanti, funzioni, main</a:t>
+              <a:t>Copilot in VS Code: token, contesto, modelli, plan e agent; leggere il codice scritto da un agente</a:t>
             </a:r>
           </a:p>
           <a:p>
@@ -10783,7 +10744,7 @@
                 <a:latin typeface="Calibri"/>
                 <a:cs typeface="Calibri"/>
               </a:rPr>
-              <a:t>Soluzioni condivise a fine giornata</a:t>
+              <a:t>Finestra con gli agenti su Plotly e pandas; soluzioni condivise a fine giornata</a:t>
             </a:r>
           </a:p>
         </p:txBody>

</xml_diff>

<commit_message>
Modulo 4: Plotly ridotto a 25 minuti, 10 a 35, capstone a 150 con lo step 7 di richieste libere a Copilot
Co-Authored-By: Claude Fable 5.1 <noreply@anthropic.com>
Claude-Session: https://claude.ai/code/session_01P1BQsLkuhRse3RJB6S6MwQ
</commit_message>
<xml_diff>
--- a/Slides/Presentazione_python_base.pptx
+++ b/Slides/Presentazione_python_base.pptx
@@ -10696,7 +10696,7 @@
                 <a:latin typeface="Calibri"/>
                 <a:cs typeface="Calibri"/>
               </a:rPr>
-              <a:t>Grafici interattivi con Plotly: linee, confronto tra serie, slider, export HTML</a:t>
+              <a:t>Plotly in breve: un grafico a linee, il confronto tra serie, l'export in HTML</a:t>
             </a:r>
           </a:p>
           <a:p>
@@ -10744,7 +10744,7 @@
                 <a:latin typeface="Calibri"/>
                 <a:cs typeface="Calibri"/>
               </a:rPr>
-              <a:t>Finestra con gli agenti su Plotly e pandas; soluzioni condivise a fine giornata</a:t>
+              <a:t>Step finale del capstone: richieste libere a Copilot sui dati, da leggere e verificare; soluzioni condivise a fine giornata</a:t>
             </a:r>
           </a:p>
         </p:txBody>

</xml_diff>